<commit_message>
docs: simplify embedding briefing next steps
</commit_message>
<xml_diff>
--- a/reports/embedding_model_progress_20260630.pptx
+++ b/reports/embedding_model_progress_20260630.pptx
@@ -3281,7 +3281,7 @@
           <a:p>
             <a:pPr>
               <a:spcAft>
-                <a:spcPts val="500"/>
+                <a:spcPts val="600"/>
               </a:spcAft>
               <a:defRPr sz="1220">
                 <a:solidFill>
@@ -3297,7 +3297,7 @@
           <a:p>
             <a:pPr>
               <a:spcAft>
-                <a:spcPts val="500"/>
+                <a:spcPts val="600"/>
               </a:spcAft>
               <a:defRPr sz="1220">
                 <a:solidFill>
@@ -3313,7 +3313,7 @@
           <a:p>
             <a:pPr>
               <a:spcAft>
-                <a:spcPts val="500"/>
+                <a:spcPts val="600"/>
               </a:spcAft>
               <a:defRPr sz="1220">
                 <a:solidFill>
@@ -4165,7 +4165,7 @@
               </a:defRPr>
             </a:pPr>
             <a:r>
-              <a:t>原则：先把训练量和标签量补上，稳步提升模型效果，不做过度承诺</a:t>
+              <a:t>原则：围绕现有模型稳步补训练、补标签、做复核，不设过高目标</a:t>
             </a:r>
           </a:p>
         </p:txBody>
@@ -4221,8 +4221,8 @@
         </p:nvSpPr>
         <p:spPr>
           <a:xfrm>
-            <a:off x="502920" y="1188720"/>
-            <a:ext cx="1508760" cy="256032"/>
+            <a:off x="594360" y="1234440"/>
+            <a:ext cx="1554480" cy="256032"/>
           </a:xfrm>
           <a:prstGeom prst="roundRect">
             <a:avLst/>
@@ -4274,8 +4274,8 @@
         </p:nvSpPr>
         <p:spPr>
           <a:xfrm>
-            <a:off x="640080" y="1600200"/>
-            <a:ext cx="5212080" cy="2148840"/>
+            <a:off x="713232" y="1664208"/>
+            <a:ext cx="5257800" cy="2468880"/>
           </a:xfrm>
           <a:prstGeom prst="rect">
             <a:avLst/>
@@ -4290,9 +4290,9 @@
           <a:p>
             <a:pPr>
               <a:spcAft>
-                <a:spcPts val="500"/>
+                <a:spcPts val="600"/>
               </a:spcAft>
-              <a:defRPr sz="1300">
+              <a:defRPr sz="1500">
                 <a:solidFill>
                   <a:srgbClr val="2D2D2D"/>
                 </a:solidFill>
@@ -4300,15 +4300,15 @@
               </a:defRPr>
             </a:pPr>
             <a:r>
-              <a:t>增加训练量：继续扩大哈尔滨新区、海淀区的训练轮次和训练样本覆盖，先验证“训练更充分后效果能否稳定提升”。</a:t>
+              <a:t>适当增加训练量，优先让当前 P2A 底座训练得更充分。</a:t>
             </a:r>
           </a:p>
           <a:p>
             <a:pPr>
               <a:spcAft>
-                <a:spcPts val="500"/>
+                <a:spcPts val="600"/>
               </a:spcAft>
-              <a:defRPr sz="1300">
+              <a:defRPr sz="1500">
                 <a:solidFill>
                   <a:srgbClr val="2D2D2D"/>
                 </a:solidFill>
@@ -4316,15 +4316,15 @@
               </a:defRPr>
             </a:pPr>
             <a:r>
-              <a:t>增加标签量：优先补建筑、道路、施工变化等已有任务的有效标签，减少 OSM/弱标注噪声对结果判断的影响。</a:t>
+              <a:t>继续补充有效标签，重点先放在已有任务和已有区域。</a:t>
             </a:r>
           </a:p>
           <a:p>
             <a:pPr>
               <a:spcAft>
-                <a:spcPts val="500"/>
+                <a:spcPts val="600"/>
               </a:spcAft>
-              <a:defRPr sz="1300">
+              <a:defRPr sz="1500">
                 <a:solidFill>
                   <a:srgbClr val="2D2D2D"/>
                 </a:solidFill>
@@ -4332,15 +4332,15 @@
               </a:defRPr>
             </a:pPr>
             <a:r>
-              <a:t>稳健迭代模型：暂不大幅扩展复杂方向，先围绕当前 P2A 底座做小步优化和复测。</a:t>
+              <a:t>保持小步迭代，每轮只做有限改动，方便判断效果变化。</a:t>
             </a:r>
           </a:p>
           <a:p>
             <a:pPr>
               <a:spcAft>
-                <a:spcPts val="500"/>
+                <a:spcPts val="600"/>
               </a:spcAft>
-              <a:defRPr sz="1300">
+              <a:defRPr sz="1500">
                 <a:solidFill>
                   <a:srgbClr val="2D2D2D"/>
                 </a:solidFill>
@@ -4348,7 +4348,7 @@
               </a:defRPr>
             </a:pPr>
             <a:r>
-              <a:t>保留典型案例：每轮训练后固定输出指标和可视化案例，方便向领导和专家解释模型变化。</a:t>
+              <a:t>保留少量典型效果图和指标，用于阶段性汇报和复核。</a:t>
             </a:r>
           </a:p>
         </p:txBody>
@@ -4361,8 +4361,8 @@
         </p:nvSpPr>
         <p:spPr>
           <a:xfrm>
-            <a:off x="6309360" y="1188720"/>
-            <a:ext cx="1508760" cy="256032"/>
+            <a:off x="6309360" y="1234440"/>
+            <a:ext cx="1554480" cy="256032"/>
           </a:xfrm>
           <a:prstGeom prst="roundRect">
             <a:avLst/>
@@ -4401,7 +4401,7 @@
               </a:defRPr>
             </a:pPr>
             <a:r>
-              <a:t>主要问题</a:t>
+              <a:t>当前问题</a:t>
             </a:r>
           </a:p>
         </p:txBody>
@@ -4414,8 +4414,8 @@
         </p:nvSpPr>
         <p:spPr>
           <a:xfrm>
-            <a:off x="6446520" y="1600200"/>
-            <a:ext cx="5074920" cy="2148840"/>
+            <a:off x="6446520" y="1664208"/>
+            <a:ext cx="5074920" cy="2468880"/>
           </a:xfrm>
           <a:prstGeom prst="rect">
             <a:avLst/>
@@ -4430,9 +4430,9 @@
           <a:p>
             <a:pPr>
               <a:spcAft>
-                <a:spcPts val="500"/>
+                <a:spcPts val="600"/>
               </a:spcAft>
-              <a:defRPr sz="1300">
+              <a:defRPr sz="1500">
                 <a:solidFill>
                   <a:srgbClr val="2D2D2D"/>
                 </a:solidFill>
@@ -4440,15 +4440,15 @@
               </a:defRPr>
             </a:pPr>
             <a:r>
-              <a:t>训练量不足：当前模型已有阶段性效果，但训练还不充分，继续提升空间主要依赖更多训练。</a:t>
+              <a:t>训练量还不够，模型效果仍有波动，继续提升需要更多训练。</a:t>
             </a:r>
           </a:p>
           <a:p>
             <a:pPr>
               <a:spcAft>
-                <a:spcPts val="500"/>
+                <a:spcPts val="600"/>
               </a:spcAft>
-              <a:defRPr sz="1300">
+              <a:defRPr sz="1500">
                 <a:solidFill>
                   <a:srgbClr val="2D2D2D"/>
                 </a:solidFill>
@@ -4456,15 +4456,15 @@
               </a:defRPr>
             </a:pPr>
             <a:r>
-              <a:t>标签量不足：有效标注样本偏少，建筑、道路、土地利用等任务仍存在标签噪声和覆盖不足。</a:t>
+              <a:t>标签量还不够，部分标签来自弱标注，质量和覆盖范围还需要补。</a:t>
             </a:r>
           </a:p>
           <a:p>
             <a:pPr>
               <a:spcAft>
-                <a:spcPts val="500"/>
+                <a:spcPts val="600"/>
               </a:spcAft>
-              <a:defRPr sz="1300">
+              <a:defRPr sz="1500">
                 <a:solidFill>
                   <a:srgbClr val="2D2D2D"/>
                 </a:solidFill>
@@ -4472,15 +4472,15 @@
               </a:defRPr>
             </a:pPr>
             <a:r>
-              <a:t>数据覆盖不足：目前主要集中在哈尔滨新区和海淀区，跨区域稳定性还需要更多样本验证。</a:t>
+              <a:t>跨区域验证还不充分，目前主要集中在哈尔滨新区和海淀区。</a:t>
             </a:r>
           </a:p>
           <a:p>
             <a:pPr>
               <a:spcAft>
-                <a:spcPts val="500"/>
+                <a:spcPts val="600"/>
               </a:spcAft>
-              <a:defRPr sz="1300">
+              <a:defRPr sz="1500">
                 <a:solidFill>
                   <a:srgbClr val="2D2D2D"/>
                 </a:solidFill>
@@ -4488,7 +4488,7 @@
               </a:defRPr>
             </a:pPr>
             <a:r>
-              <a:t>算力需要持续保障：多时相 embedding 训练和导出成本较高，后续增加训练量需要稳定算力。</a:t>
+              <a:t>训练和导出 embedding 对算力有一定依赖，需要稳定计算资源。</a:t>
             </a:r>
           </a:p>
         </p:txBody>
@@ -4501,8 +4501,8 @@
         </p:nvSpPr>
         <p:spPr>
           <a:xfrm>
-            <a:off x="502920" y="4069080"/>
-            <a:ext cx="1874519" cy="256032"/>
+            <a:off x="594360" y="4526280"/>
+            <a:ext cx="1737360" cy="256032"/>
           </a:xfrm>
           <a:prstGeom prst="roundRect">
             <a:avLst/>
@@ -4541,7 +4541,7 @@
               </a:defRPr>
             </a:pPr>
             <a:r>
-              <a:t>近期执行安排</a:t>
+              <a:t>近期重点</a:t>
             </a:r>
           </a:p>
         </p:txBody>
@@ -4554,8 +4554,8 @@
         </p:nvSpPr>
         <p:spPr>
           <a:xfrm>
-            <a:off x="640080" y="4480560"/>
-            <a:ext cx="2542032" cy="960120"/>
+            <a:off x="868680" y="4956048"/>
+            <a:ext cx="3246120" cy="868680"/>
           </a:xfrm>
           <a:prstGeom prst="roundRect">
             <a:avLst/>
@@ -4584,11 +4584,11 @@
           </a:fontRef>
         </p:style>
         <p:txBody>
-          <a:bodyPr rtlCol="0" anchor="ctr" lIns="109728" rIns="109728" tIns="73152"/>
+          <a:bodyPr rtlCol="0" anchor="ctr" lIns="128016" rIns="128016" tIns="73152"/>
           <a:lstStyle/>
           <a:p>
             <a:pPr algn="ctr">
-              <a:defRPr sz="1200" b="1">
+              <a:defRPr sz="1400" b="1">
                 <a:solidFill>
                   <a:srgbClr val="2F75B5"/>
                 </a:solidFill>
@@ -4596,12 +4596,12 @@
               </a:defRPr>
             </a:pPr>
             <a:r>
-              <a:t>第 1 步</a:t>
+              <a:t>补训练</a:t>
             </a:r>
           </a:p>
           <a:p>
             <a:pPr>
-              <a:defRPr sz="1030">
+              <a:defRPr sz="1150">
                 <a:solidFill>
                   <a:srgbClr val="2D2D2D"/>
                 </a:solidFill>
@@ -4609,7 +4609,7 @@
               </a:defRPr>
             </a:pPr>
             <a:r>
-              <a:t>整理现有训练样本与标签清单，确认哪些区域、哪些任务最缺标签。</a:t>
+              <a:t>在现有数据和模型基础上增加训练量，先观察效果是否稳定变好。</a:t>
             </a:r>
           </a:p>
         </p:txBody>
@@ -4622,8 +4622,8 @@
         </p:nvSpPr>
         <p:spPr>
           <a:xfrm>
-            <a:off x="3493008" y="4480560"/>
-            <a:ext cx="2542032" cy="960120"/>
+            <a:off x="4572000" y="4956048"/>
+            <a:ext cx="3246120" cy="868680"/>
           </a:xfrm>
           <a:prstGeom prst="roundRect">
             <a:avLst/>
@@ -4652,11 +4652,11 @@
           </a:fontRef>
         </p:style>
         <p:txBody>
-          <a:bodyPr rtlCol="0" anchor="ctr" lIns="109728" rIns="109728" tIns="73152"/>
+          <a:bodyPr rtlCol="0" anchor="ctr" lIns="128016" rIns="128016" tIns="73152"/>
           <a:lstStyle/>
           <a:p>
             <a:pPr algn="ctr">
-              <a:defRPr sz="1200" b="1">
+              <a:defRPr sz="1400" b="1">
                 <a:solidFill>
                   <a:srgbClr val="2F75B5"/>
                 </a:solidFill>
@@ -4664,12 +4664,12 @@
               </a:defRPr>
             </a:pPr>
             <a:r>
-              <a:t>第 2 步</a:t>
+              <a:t>补标签</a:t>
             </a:r>
           </a:p>
           <a:p>
             <a:pPr>
-              <a:defRPr sz="1030">
+              <a:defRPr sz="1150">
                 <a:solidFill>
                   <a:srgbClr val="2D2D2D"/>
                 </a:solidFill>
@@ -4677,7 +4677,7 @@
               </a:defRPr>
             </a:pPr>
             <a:r>
-              <a:t>在现有 P2A 底座上增加训练量，优先看变化检测、建筑提取、道路提取是否稳定提升。</a:t>
+              <a:t>优先补当前任务需要的标签，减少标签不足对模型判断的影响。</a:t>
             </a:r>
           </a:p>
         </p:txBody>
@@ -4690,8 +4690,8 @@
         </p:nvSpPr>
         <p:spPr>
           <a:xfrm>
-            <a:off x="6345936" y="4480560"/>
-            <a:ext cx="2542032" cy="960120"/>
+            <a:off x="8275319" y="4956048"/>
+            <a:ext cx="3246120" cy="868680"/>
           </a:xfrm>
           <a:prstGeom prst="roundRect">
             <a:avLst/>
@@ -4720,11 +4720,11 @@
           </a:fontRef>
         </p:style>
         <p:txBody>
-          <a:bodyPr rtlCol="0" anchor="ctr" lIns="109728" rIns="109728" tIns="73152"/>
+          <a:bodyPr rtlCol="0" anchor="ctr" lIns="128016" rIns="128016" tIns="73152"/>
           <a:lstStyle/>
           <a:p>
             <a:pPr algn="ctr">
-              <a:defRPr sz="1200" b="1">
+              <a:defRPr sz="1400" b="1">
                 <a:solidFill>
                   <a:srgbClr val="2F75B5"/>
                 </a:solidFill>
@@ -4732,12 +4732,12 @@
               </a:defRPr>
             </a:pPr>
             <a:r>
-              <a:t>第 3 步</a:t>
+              <a:t>做复核</a:t>
             </a:r>
           </a:p>
           <a:p>
             <a:pPr>
-              <a:defRPr sz="1030">
+              <a:defRPr sz="1150">
                 <a:solidFill>
                   <a:srgbClr val="2D2D2D"/>
                 </a:solidFill>
@@ -4745,89 +4745,21 @@
               </a:defRPr>
             </a:pPr>
             <a:r>
-              <a:t>补充一批高质量标签或人工抽检样本，用于校验模型是否真的变好。</a:t>
-            </a:r>
-          </a:p>
-        </p:txBody>
-      </p:sp>
-      <p:sp>
-        <p:nvSpPr>
-          <p:cNvPr id="13" name="Rounded Rectangle 12"/>
+              <a:t>每次更新后保留简洁指标和典型图，避免只看单个样例下结论。</a:t>
+            </a:r>
+          </a:p>
+        </p:txBody>
+      </p:sp>
+      <p:sp>
+        <p:nvSpPr>
+          <p:cNvPr id="13" name="Rectangle 12"/>
           <p:cNvSpPr/>
           <p:nvPr/>
         </p:nvSpPr>
         <p:spPr>
           <a:xfrm>
-            <a:off x="9198863" y="4480560"/>
-            <a:ext cx="2542032" cy="960120"/>
-          </a:xfrm>
-          <a:prstGeom prst="roundRect">
-            <a:avLst/>
-          </a:prstGeom>
-          <a:solidFill>
-            <a:srgbClr val="F5F7FA"/>
-          </a:solidFill>
-          <a:ln>
-            <a:solidFill>
-              <a:srgbClr val="D2D8E0"/>
-            </a:solidFill>
-          </a:ln>
-        </p:spPr>
-        <p:style>
-          <a:lnRef idx="1">
-            <a:schemeClr val="accent1"/>
-          </a:lnRef>
-          <a:fillRef idx="3">
-            <a:schemeClr val="accent1"/>
-          </a:fillRef>
-          <a:effectRef idx="2">
-            <a:schemeClr val="accent1"/>
-          </a:effectRef>
-          <a:fontRef idx="minor">
-            <a:schemeClr val="lt1"/>
-          </a:fontRef>
-        </p:style>
-        <p:txBody>
-          <a:bodyPr rtlCol="0" anchor="ctr" lIns="109728" rIns="109728" tIns="73152"/>
-          <a:lstStyle/>
-          <a:p>
-            <a:pPr algn="ctr">
-              <a:defRPr sz="1200" b="1">
-                <a:solidFill>
-                  <a:srgbClr val="2F75B5"/>
-                </a:solidFill>
-                <a:latin typeface="Microsoft YaHei"/>
-              </a:defRPr>
-            </a:pPr>
-            <a:r>
-              <a:t>第 4 步</a:t>
-            </a:r>
-          </a:p>
-          <a:p>
-            <a:pPr>
-              <a:defRPr sz="1030">
-                <a:solidFill>
-                  <a:srgbClr val="2D2D2D"/>
-                </a:solidFill>
-                <a:latin typeface="Microsoft YaHei"/>
-              </a:defRPr>
-            </a:pPr>
-            <a:r>
-              <a:t>输出一版简洁评估材料：指标表 + 典型效果图 + 问题样例。</a:t>
-            </a:r>
-          </a:p>
-        </p:txBody>
-      </p:sp>
-      <p:sp>
-        <p:nvSpPr>
-          <p:cNvPr id="14" name="Rectangle 13"/>
-          <p:cNvSpPr/>
-          <p:nvPr/>
-        </p:nvSpPr>
-        <p:spPr>
-          <a:xfrm>
-            <a:off x="502920" y="5797296"/>
-            <a:ext cx="11155680" cy="420624"/>
+            <a:off x="594360" y="6053328"/>
+            <a:ext cx="10972800" cy="384048"/>
           </a:xfrm>
           <a:prstGeom prst="rect">
             <a:avLst/>
@@ -4866,7 +4798,7 @@
               </a:defRPr>
             </a:pPr>
             <a:r>
-              <a:t>阶段目标：不把目标提得过高，先通过“增加训练量 + 增加标签量”把现有模型效果做稳，再决定是否扩展更多区域和任务。</a:t>
+              <a:t>阶段目标：先把现有模型做稳，把训练量和标签量补上，再根据实际效果决定后续扩展。</a:t>
             </a:r>
           </a:p>
         </p:txBody>

</xml_diff>